<commit_message>
switch A0 posters from three to two columns
Wider columns read more comfortably at A0 viewing distance. Column 1
now carries Introduction + Method; Column 2 stacks Results (with a
larger figure placeholder), Conclusion, References, and
Acknowledgements. Column gap widened slightly to compensate.

Co-Authored-By: Claude Opus 4.7 (1M context) <noreply@anthropic.com>
</commit_message>
<xml_diff>
--- a/templates/royal_blue/KCLNLP_RoyalBlue_Poster.pptx
+++ b/templates/royal_blue/KCLNLP_RoyalBlue_Poster.pptx
@@ -3351,7 +3351,7 @@
         </p:nvCxnSpPr>
         <p:spPr>
           <a:xfrm>
-            <a:off x="10244388" y="6858000"/>
+            <a:off x="15137983" y="6858000"/>
             <a:ext cx="0" cy="33751418"/>
           </a:xfrm>
           <a:prstGeom prst="line">
@@ -3378,21 +3378,56 @@
           </a:fontRef>
         </p:style>
       </p:cxnSp>
+      <p:sp>
+        <p:nvSpPr>
+          <p:cNvPr id="11" name="TextBox 10"/>
+          <p:cNvSpPr txBox="1"/>
+          <p:nvPr/>
+        </p:nvSpPr>
+        <p:spPr>
+          <a:xfrm>
+            <a:off x="914400" y="6400800"/>
+            <a:ext cx="13674943" cy="822960"/>
+          </a:xfrm>
+          <a:prstGeom prst="rect">
+            <a:avLst/>
+          </a:prstGeom>
+          <a:noFill/>
+        </p:spPr>
+        <p:txBody>
+          <a:bodyPr wrap="square" lIns="0" rIns="0" tIns="0" bIns="0" anchor="t">
+            <a:spAutoFit/>
+          </a:bodyPr>
+          <a:lstStyle/>
+          <a:p>
+            <a:pPr algn="l"/>
+            <a:r>
+              <a:rPr sz="4800" b="1" i="0">
+                <a:solidFill>
+                  <a:srgbClr val="15296B"/>
+                </a:solidFill>
+                <a:latin typeface="Calibri"/>
+              </a:rPr>
+              <a:t>Introduction</a:t>
+            </a:r>
+          </a:p>
+        </p:txBody>
+      </p:sp>
       <p:cxnSp>
         <p:nvCxnSpPr>
-          <p:cNvPr id="11" name="Connector 10"/>
+          <p:cNvPr id="12" name="Connector 11"/>
           <p:cNvCxnSpPr/>
           <p:nvPr/>
         </p:nvCxnSpPr>
         <p:spPr>
           <a:xfrm>
-            <a:off x="20031576" y="6858000"/>
-            <a:ext cx="0" cy="33751418"/>
+            <a:off x="914400" y="7269480"/>
+            <a:ext cx="2286000" cy="0"/>
           </a:xfrm>
           <a:prstGeom prst="line">
             <a:avLst/>
           </a:prstGeom>
-          <a:ln w="12700">
+          <a:ln w="38100">
             <a:solidFill>
               <a:srgbClr val="1F3A93"/>
             </a:solidFill>
@@ -3415,14 +3450,14 @@
       </p:cxnSp>
       <p:sp>
         <p:nvSpPr>
-          <p:cNvPr id="12" name="TextBox 11"/>
+          <p:cNvPr id="13" name="TextBox 12"/>
           <p:cNvSpPr txBox="1"/>
           <p:nvPr/>
         </p:nvSpPr>
         <p:spPr>
           <a:xfrm>
-            <a:off x="914400" y="6400800"/>
-            <a:ext cx="8872788" cy="822960"/>
+            <a:off x="914400" y="7498080"/>
+            <a:ext cx="13674943" cy="4572000"/>
           </a:xfrm>
           <a:prstGeom prst="rect">
             <a:avLst/>
@@ -3437,26 +3472,61 @@
           <a:p>
             <a:pPr algn="l"/>
             <a:r>
-              <a:rPr sz="4800" b="1" i="0">
-                <a:solidFill>
-                  <a:srgbClr val="15296B"/>
+              <a:rPr sz="2600" b="0" i="0">
+                <a:solidFill>
+                  <a:srgbClr val="1F1F1F"/>
                 </a:solidFill>
                 <a:latin typeface="Calibri"/>
               </a:rPr>
-              <a:t>Introduction</a:t>
+              <a:t>Open with the problem and why it matters. Frame the gap in prior work and state the contribution in one sentence. Use this wider column to set up the context the reader needs to understand the method and results.</a:t>
+            </a:r>
+          </a:p>
+        </p:txBody>
+      </p:sp>
+      <p:sp>
+        <p:nvSpPr>
+          <p:cNvPr id="14" name="TextBox 13"/>
+          <p:cNvSpPr txBox="1"/>
+          <p:nvPr/>
+        </p:nvSpPr>
+        <p:spPr>
+          <a:xfrm>
+            <a:off x="914400" y="12435840"/>
+            <a:ext cx="13674943" cy="822960"/>
+          </a:xfrm>
+          <a:prstGeom prst="rect">
+            <a:avLst/>
+          </a:prstGeom>
+          <a:noFill/>
+        </p:spPr>
+        <p:txBody>
+          <a:bodyPr wrap="square" lIns="0" rIns="0" tIns="0" bIns="0" anchor="t">
+            <a:spAutoFit/>
+          </a:bodyPr>
+          <a:lstStyle/>
+          <a:p>
+            <a:pPr algn="l"/>
+            <a:r>
+              <a:rPr sz="4800" b="1" i="0">
+                <a:solidFill>
+                  <a:srgbClr val="15296B"/>
+                </a:solidFill>
+                <a:latin typeface="Calibri"/>
+              </a:rPr>
+              <a:t>Method</a:t>
             </a:r>
           </a:p>
         </p:txBody>
       </p:sp>
       <p:cxnSp>
         <p:nvCxnSpPr>
-          <p:cNvPr id="13" name="Connector 12"/>
+          <p:cNvPr id="15" name="Connector 14"/>
           <p:cNvCxnSpPr/>
           <p:nvPr/>
         </p:nvCxnSpPr>
         <p:spPr>
           <a:xfrm>
-            <a:off x="914400" y="7269480"/>
+            <a:off x="914400" y="13304520"/>
             <a:ext cx="2286000" cy="0"/>
           </a:xfrm>
           <a:prstGeom prst="line">
@@ -3485,14 +3555,14 @@
       </p:cxnSp>
       <p:sp>
         <p:nvSpPr>
-          <p:cNvPr id="14" name="TextBox 13"/>
+          <p:cNvPr id="16" name="TextBox 15"/>
           <p:cNvSpPr txBox="1"/>
           <p:nvPr/>
         </p:nvSpPr>
         <p:spPr>
           <a:xfrm>
-            <a:off x="914400" y="7498080"/>
-            <a:ext cx="8872788" cy="3657600"/>
+            <a:off x="914400" y="13533120"/>
+            <a:ext cx="13674943" cy="18288000"/>
           </a:xfrm>
           <a:prstGeom prst="rect">
             <a:avLst/>
@@ -3500,34 +3570,102 @@
           <a:noFill/>
         </p:spPr>
         <p:txBody>
-          <a:bodyPr wrap="square" lIns="0" rIns="0" tIns="0" bIns="0" anchor="t">
+          <a:bodyPr wrap="square" lIns="0" rIns="0" tIns="0" bIns="0">
             <a:spAutoFit/>
           </a:bodyPr>
           <a:lstStyle/>
           <a:p>
-            <a:pPr algn="l"/>
-            <a:r>
-              <a:rPr sz="2600" b="0" i="0">
+            <a:pPr algn="l">
+              <a:spcAft>
+                <a:spcPts val="1400"/>
+              </a:spcAft>
+            </a:pPr>
+            <a:r>
+              <a:rPr sz="2600">
                 <a:solidFill>
                   <a:srgbClr val="1F1F1F"/>
                 </a:solidFill>
                 <a:latin typeface="Calibri"/>
               </a:rPr>
-              <a:t>Open with the problem and why it matters. Frame the gap in prior work and state the contribution in one sentence.</a:t>
-            </a:r>
-          </a:p>
-        </p:txBody>
-      </p:sp>
-      <p:sp>
-        <p:nvSpPr>
-          <p:cNvPr id="15" name="TextBox 14"/>
+              <a:t>•  Dataset — what you used and how it was collected</a:t>
+            </a:r>
+          </a:p>
+          <a:p>
+            <a:pPr algn="l">
+              <a:spcAft>
+                <a:spcPts val="1400"/>
+              </a:spcAft>
+            </a:pPr>
+            <a:r>
+              <a:rPr sz="2600">
+                <a:solidFill>
+                  <a:srgbClr val="1F1F1F"/>
+                </a:solidFill>
+                <a:latin typeface="Calibri"/>
+              </a:rPr>
+              <a:t>•  Model / algorithm — architecture, training regime, hyper-parameters</a:t>
+            </a:r>
+          </a:p>
+          <a:p>
+            <a:pPr algn="l">
+              <a:spcAft>
+                <a:spcPts val="1400"/>
+              </a:spcAft>
+            </a:pPr>
+            <a:r>
+              <a:rPr sz="2600">
+                <a:solidFill>
+                  <a:srgbClr val="1F1F1F"/>
+                </a:solidFill>
+                <a:latin typeface="Calibri"/>
+              </a:rPr>
+              <a:t>•  Evaluation — metrics, baselines, held-out sets</a:t>
+            </a:r>
+          </a:p>
+          <a:p>
+            <a:pPr algn="l">
+              <a:spcAft>
+                <a:spcPts val="1400"/>
+              </a:spcAft>
+            </a:pPr>
+            <a:r>
+              <a:rPr sz="2600">
+                <a:solidFill>
+                  <a:srgbClr val="1F1F1F"/>
+                </a:solidFill>
+                <a:latin typeface="Calibri"/>
+              </a:rPr>
+              <a:t>•  Implementation — reproducibility notes, compute budget</a:t>
+            </a:r>
+          </a:p>
+          <a:p>
+            <a:pPr algn="l">
+              <a:spcAft>
+                <a:spcPts val="1400"/>
+              </a:spcAft>
+            </a:pPr>
+            <a:r>
+              <a:rPr sz="2600">
+                <a:solidFill>
+                  <a:srgbClr val="1F1F1F"/>
+                </a:solidFill>
+                <a:latin typeface="Calibri"/>
+              </a:rPr>
+              <a:t>•  Ablation — what you varied to isolate each effect</a:t>
+            </a:r>
+          </a:p>
+        </p:txBody>
+      </p:sp>
+      <p:sp>
+        <p:nvSpPr>
+          <p:cNvPr id="17" name="TextBox 16"/>
           <p:cNvSpPr txBox="1"/>
           <p:nvPr/>
         </p:nvSpPr>
         <p:spPr>
           <a:xfrm>
-            <a:off x="914400" y="11430000"/>
-            <a:ext cx="8872788" cy="822960"/>
+            <a:off x="15686623" y="6400800"/>
+            <a:ext cx="13674943" cy="822960"/>
           </a:xfrm>
           <a:prstGeom prst="rect">
             <a:avLst/>
@@ -3548,20 +3686,20 @@
                 </a:solidFill>
                 <a:latin typeface="Calibri"/>
               </a:rPr>
-              <a:t>Method</a:t>
+              <a:t>Results</a:t>
             </a:r>
           </a:p>
         </p:txBody>
       </p:sp>
       <p:cxnSp>
         <p:nvCxnSpPr>
-          <p:cNvPr id="16" name="Connector 15"/>
+          <p:cNvPr id="18" name="Connector 17"/>
           <p:cNvCxnSpPr/>
           <p:nvPr/>
         </p:nvCxnSpPr>
         <p:spPr>
           <a:xfrm>
-            <a:off x="914400" y="12298680"/>
+            <a:off x="15686623" y="7269480"/>
             <a:ext cx="2286000" cy="0"/>
           </a:xfrm>
           <a:prstGeom prst="line">
@@ -3590,14 +3728,127 @@
       </p:cxnSp>
       <p:sp>
         <p:nvSpPr>
-          <p:cNvPr id="17" name="TextBox 16"/>
+          <p:cNvPr id="19" name="Rectangle 18"/>
+          <p:cNvSpPr/>
+          <p:nvPr/>
+        </p:nvSpPr>
+        <p:spPr>
+          <a:xfrm>
+            <a:off x="15686623" y="7498080"/>
+            <a:ext cx="13674943" cy="9144000"/>
+          </a:xfrm>
+          <a:prstGeom prst="rect">
+            <a:avLst/>
+          </a:prstGeom>
+          <a:noFill/>
+          <a:ln w="19050">
+            <a:solidFill>
+              <a:srgbClr val="1F3A93"/>
+            </a:solidFill>
+          </a:ln>
+        </p:spPr>
+        <p:style>
+          <a:lnRef idx="1">
+            <a:schemeClr val="accent1"/>
+          </a:lnRef>
+          <a:fillRef idx="3">
+            <a:schemeClr val="accent1"/>
+          </a:fillRef>
+          <a:effectRef idx="2">
+            <a:schemeClr val="accent1"/>
+          </a:effectRef>
+          <a:fontRef idx="minor">
+            <a:schemeClr val="lt1"/>
+          </a:fontRef>
+        </p:style>
+        <p:txBody>
+          <a:bodyPr rtlCol="0" anchor="ctr"/>
+          <a:lstStyle/>
+          <a:p>
+            <a:pPr algn="ctr"/>
+          </a:p>
+        </p:txBody>
+      </p:sp>
+      <p:sp>
+        <p:nvSpPr>
+          <p:cNvPr id="20" name="TextBox 19"/>
           <p:cNvSpPr txBox="1"/>
           <p:nvPr/>
         </p:nvSpPr>
         <p:spPr>
           <a:xfrm>
-            <a:off x="914400" y="12527280"/>
-            <a:ext cx="8872788" cy="14630400"/>
+            <a:off x="15686623" y="7498080"/>
+            <a:ext cx="13674943" cy="9144000"/>
+          </a:xfrm>
+          <a:prstGeom prst="rect">
+            <a:avLst/>
+          </a:prstGeom>
+          <a:noFill/>
+        </p:spPr>
+        <p:txBody>
+          <a:bodyPr wrap="square" lIns="0" rIns="0" tIns="0" bIns="0" anchor="ctr">
+            <a:spAutoFit/>
+          </a:bodyPr>
+          <a:lstStyle/>
+          <a:p>
+            <a:pPr algn="ctr"/>
+            <a:r>
+              <a:rPr sz="2800" b="0" i="1">
+                <a:solidFill>
+                  <a:srgbClr val="555555"/>
+                </a:solidFill>
+                <a:latin typeface="Calibri"/>
+              </a:rPr>
+              <a:t>[ figure / diagram ]</a:t>
+            </a:r>
+          </a:p>
+        </p:txBody>
+      </p:sp>
+      <p:sp>
+        <p:nvSpPr>
+          <p:cNvPr id="21" name="TextBox 20"/>
+          <p:cNvSpPr txBox="1"/>
+          <p:nvPr/>
+        </p:nvSpPr>
+        <p:spPr>
+          <a:xfrm>
+            <a:off x="15686623" y="16779240"/>
+            <a:ext cx="13674943" cy="457200"/>
+          </a:xfrm>
+          <a:prstGeom prst="rect">
+            <a:avLst/>
+          </a:prstGeom>
+          <a:noFill/>
+        </p:spPr>
+        <p:txBody>
+          <a:bodyPr wrap="square" lIns="0" rIns="0" tIns="0" bIns="0" anchor="t">
+            <a:spAutoFit/>
+          </a:bodyPr>
+          <a:lstStyle/>
+          <a:p>
+            <a:pPr algn="l"/>
+            <a:r>
+              <a:rPr sz="2000" b="0" i="1">
+                <a:solidFill>
+                  <a:srgbClr val="555555"/>
+                </a:solidFill>
+                <a:latin typeface="Calibri"/>
+              </a:rPr>
+              <a:t>Figure 1. Main result — replace this box with your chart.</a:t>
+            </a:r>
+          </a:p>
+        </p:txBody>
+      </p:sp>
+      <p:sp>
+        <p:nvSpPr>
+          <p:cNvPr id="22" name="TextBox 21"/>
+          <p:cNvSpPr txBox="1"/>
+          <p:nvPr/>
+        </p:nvSpPr>
+        <p:spPr>
+          <a:xfrm>
+            <a:off x="15686623" y="17556480"/>
+            <a:ext cx="13674943" cy="5943600"/>
           </a:xfrm>
           <a:prstGeom prst="rect">
             <a:avLst/>
@@ -3622,7 +3873,7 @@
                 </a:solidFill>
                 <a:latin typeface="Calibri"/>
               </a:rPr>
-              <a:t>•  Dataset — what you used and how it was collected</a:t>
+              <a:t>•  Headline number — the single result the reader must remember</a:t>
             </a:r>
           </a:p>
           <a:p>
@@ -3638,7 +3889,7 @@
                 </a:solidFill>
                 <a:latin typeface="Calibri"/>
               </a:rPr>
-              <a:t>•  Model / algorithm — architecture, training regime, hyper-parameters</a:t>
+              <a:t>•  Second finding — what changed when you varied X</a:t>
             </a:r>
           </a:p>
           <a:p>
@@ -3654,7 +3905,7 @@
                 </a:solidFill>
                 <a:latin typeface="Calibri"/>
               </a:rPr>
-              <a:t>•  Evaluation — metrics, baselines, held-out sets</a:t>
+              <a:t>•  Error analysis — where the method still fails</a:t>
             </a:r>
           </a:p>
           <a:p>
@@ -3670,37 +3921,21 @@
                 </a:solidFill>
                 <a:latin typeface="Calibri"/>
               </a:rPr>
-              <a:t>•  Implementation — reproducibility notes, compute budget</a:t>
-            </a:r>
-          </a:p>
-          <a:p>
-            <a:pPr algn="l">
-              <a:spcAft>
-                <a:spcPts val="1400"/>
-              </a:spcAft>
-            </a:pPr>
-            <a:r>
-              <a:rPr sz="2600">
-                <a:solidFill>
-                  <a:srgbClr val="1F1F1F"/>
-                </a:solidFill>
-                <a:latin typeface="Calibri"/>
-              </a:rPr>
-              <a:t>•  Ablation — what you varied to isolate each effect</a:t>
-            </a:r>
-          </a:p>
-        </p:txBody>
-      </p:sp>
-      <p:sp>
-        <p:nvSpPr>
-          <p:cNvPr id="18" name="TextBox 17"/>
+              <a:t>•  Comparison — how this relates to the strongest baseline</a:t>
+            </a:r>
+          </a:p>
+        </p:txBody>
+      </p:sp>
+      <p:sp>
+        <p:nvSpPr>
+          <p:cNvPr id="23" name="TextBox 22"/>
           <p:cNvSpPr txBox="1"/>
           <p:nvPr/>
         </p:nvSpPr>
         <p:spPr>
           <a:xfrm>
-            <a:off x="10701588" y="6400800"/>
-            <a:ext cx="8872788" cy="822960"/>
+            <a:off x="15686623" y="23865840"/>
+            <a:ext cx="13674943" cy="822960"/>
           </a:xfrm>
           <a:prstGeom prst="rect">
             <a:avLst/>
@@ -3721,20 +3956,20 @@
                 </a:solidFill>
                 <a:latin typeface="Calibri"/>
               </a:rPr>
-              <a:t>Results</a:t>
+              <a:t>Conclusion</a:t>
             </a:r>
           </a:p>
         </p:txBody>
       </p:sp>
       <p:cxnSp>
         <p:nvCxnSpPr>
-          <p:cNvPr id="19" name="Connector 18"/>
+          <p:cNvPr id="24" name="Connector 23"/>
           <p:cNvCxnSpPr/>
           <p:nvPr/>
         </p:nvCxnSpPr>
         <p:spPr>
           <a:xfrm>
-            <a:off x="10701588" y="7269480"/>
+            <a:off x="15686623" y="24734520"/>
             <a:ext cx="2286000" cy="0"/>
           </a:xfrm>
           <a:prstGeom prst="line">
@@ -3763,57 +3998,49 @@
       </p:cxnSp>
       <p:sp>
         <p:nvSpPr>
-          <p:cNvPr id="20" name="Rectangle 19"/>
-          <p:cNvSpPr/>
+          <p:cNvPr id="25" name="TextBox 24"/>
+          <p:cNvSpPr txBox="1"/>
           <p:nvPr/>
         </p:nvSpPr>
         <p:spPr>
           <a:xfrm>
-            <a:off x="10701588" y="7498080"/>
-            <a:ext cx="8872788" cy="8229600"/>
+            <a:off x="15686623" y="24963120"/>
+            <a:ext cx="13674943" cy="3657600"/>
           </a:xfrm>
           <a:prstGeom prst="rect">
             <a:avLst/>
           </a:prstGeom>
           <a:noFill/>
-          <a:ln w="19050">
-            <a:solidFill>
-              <a:srgbClr val="1F3A93"/>
-            </a:solidFill>
-          </a:ln>
-        </p:spPr>
-        <p:style>
-          <a:lnRef idx="1">
-            <a:schemeClr val="accent1"/>
-          </a:lnRef>
-          <a:fillRef idx="3">
-            <a:schemeClr val="accent1"/>
-          </a:fillRef>
-          <a:effectRef idx="2">
-            <a:schemeClr val="accent1"/>
-          </a:effectRef>
-          <a:fontRef idx="minor">
-            <a:schemeClr val="lt1"/>
-          </a:fontRef>
-        </p:style>
-        <p:txBody>
-          <a:bodyPr rtlCol="0" anchor="ctr"/>
-          <a:lstStyle/>
-          <a:p>
-            <a:pPr algn="ctr"/>
-          </a:p>
-        </p:txBody>
-      </p:sp>
-      <p:sp>
-        <p:nvSpPr>
-          <p:cNvPr id="21" name="TextBox 20"/>
+        </p:spPr>
+        <p:txBody>
+          <a:bodyPr wrap="square" lIns="0" rIns="0" tIns="0" bIns="0" anchor="t">
+            <a:spAutoFit/>
+          </a:bodyPr>
+          <a:lstStyle/>
+          <a:p>
+            <a:pPr algn="l"/>
+            <a:r>
+              <a:rPr sz="2600" b="0" i="0">
+                <a:solidFill>
+                  <a:srgbClr val="1F1F1F"/>
+                </a:solidFill>
+                <a:latin typeface="Calibri"/>
+              </a:rPr>
+              <a:t>Restate the contribution in the terms of the result. Note the one limitation that most shapes when to use (or not use) this approach, and point to the next question it opens up.</a:t>
+            </a:r>
+          </a:p>
+        </p:txBody>
+      </p:sp>
+      <p:sp>
+        <p:nvSpPr>
+          <p:cNvPr id="26" name="TextBox 25"/>
           <p:cNvSpPr txBox="1"/>
           <p:nvPr/>
         </p:nvSpPr>
         <p:spPr>
           <a:xfrm>
-            <a:off x="10701588" y="7498080"/>
-            <a:ext cx="8872788" cy="8229600"/>
+            <a:off x="15686623" y="28895040"/>
+            <a:ext cx="13674943" cy="822960"/>
           </a:xfrm>
           <a:prstGeom prst="rect">
             <a:avLst/>
@@ -3821,41 +4048,6 @@
           <a:noFill/>
         </p:spPr>
         <p:txBody>
-          <a:bodyPr wrap="square" lIns="0" rIns="0" tIns="0" bIns="0" anchor="ctr">
-            <a:spAutoFit/>
-          </a:bodyPr>
-          <a:lstStyle/>
-          <a:p>
-            <a:pPr algn="ctr"/>
-            <a:r>
-              <a:rPr sz="2800" b="0" i="1">
-                <a:solidFill>
-                  <a:srgbClr val="555555"/>
-                </a:solidFill>
-                <a:latin typeface="Calibri"/>
-              </a:rPr>
-              <a:t>[ figure / diagram ]</a:t>
-            </a:r>
-          </a:p>
-        </p:txBody>
-      </p:sp>
-      <p:sp>
-        <p:nvSpPr>
-          <p:cNvPr id="22" name="TextBox 21"/>
-          <p:cNvSpPr txBox="1"/>
-          <p:nvPr/>
-        </p:nvSpPr>
-        <p:spPr>
-          <a:xfrm>
-            <a:off x="10701588" y="15864840"/>
-            <a:ext cx="8872788" cy="457200"/>
-          </a:xfrm>
-          <a:prstGeom prst="rect">
-            <a:avLst/>
-          </a:prstGeom>
-          <a:noFill/>
-        </p:spPr>
-        <p:txBody>
           <a:bodyPr wrap="square" lIns="0" rIns="0" tIns="0" bIns="0" anchor="t">
             <a:spAutoFit/>
           </a:bodyPr>
@@ -3863,148 +4055,26 @@
           <a:p>
             <a:pPr algn="l"/>
             <a:r>
-              <a:rPr sz="2000" b="0" i="1">
-                <a:solidFill>
-                  <a:srgbClr val="555555"/>
+              <a:rPr sz="4800" b="1" i="0">
+                <a:solidFill>
+                  <a:srgbClr val="15296B"/>
                 </a:solidFill>
                 <a:latin typeface="Calibri"/>
               </a:rPr>
-              <a:t>Figure 1. Main result — replace this box with your chart.</a:t>
-            </a:r>
-          </a:p>
-        </p:txBody>
-      </p:sp>
-      <p:sp>
-        <p:nvSpPr>
-          <p:cNvPr id="23" name="TextBox 22"/>
-          <p:cNvSpPr txBox="1"/>
-          <p:nvPr/>
-        </p:nvSpPr>
-        <p:spPr>
-          <a:xfrm>
-            <a:off x="10701588" y="16642080"/>
-            <a:ext cx="8872788" cy="9144000"/>
-          </a:xfrm>
-          <a:prstGeom prst="rect">
-            <a:avLst/>
-          </a:prstGeom>
-          <a:noFill/>
-        </p:spPr>
-        <p:txBody>
-          <a:bodyPr wrap="square" lIns="0" rIns="0" tIns="0" bIns="0">
-            <a:spAutoFit/>
-          </a:bodyPr>
-          <a:lstStyle/>
-          <a:p>
-            <a:pPr algn="l">
-              <a:spcAft>
-                <a:spcPts val="1400"/>
-              </a:spcAft>
-            </a:pPr>
-            <a:r>
-              <a:rPr sz="2600">
-                <a:solidFill>
-                  <a:srgbClr val="1F1F1F"/>
-                </a:solidFill>
-                <a:latin typeface="Calibri"/>
-              </a:rPr>
-              <a:t>•  Headline number — the single result the reader must remember</a:t>
-            </a:r>
-          </a:p>
-          <a:p>
-            <a:pPr algn="l">
-              <a:spcAft>
-                <a:spcPts val="1400"/>
-              </a:spcAft>
-            </a:pPr>
-            <a:r>
-              <a:rPr sz="2600">
-                <a:solidFill>
-                  <a:srgbClr val="1F1F1F"/>
-                </a:solidFill>
-                <a:latin typeface="Calibri"/>
-              </a:rPr>
-              <a:t>•  Second finding — what changed when you varied X</a:t>
-            </a:r>
-          </a:p>
-          <a:p>
-            <a:pPr algn="l">
-              <a:spcAft>
-                <a:spcPts val="1400"/>
-              </a:spcAft>
-            </a:pPr>
-            <a:r>
-              <a:rPr sz="2600">
-                <a:solidFill>
-                  <a:srgbClr val="1F1F1F"/>
-                </a:solidFill>
-                <a:latin typeface="Calibri"/>
-              </a:rPr>
-              <a:t>•  Error analysis — where the method still fails</a:t>
-            </a:r>
-          </a:p>
-          <a:p>
-            <a:pPr algn="l">
-              <a:spcAft>
-                <a:spcPts val="1400"/>
-              </a:spcAft>
-            </a:pPr>
-            <a:r>
-              <a:rPr sz="2600">
-                <a:solidFill>
-                  <a:srgbClr val="1F1F1F"/>
-                </a:solidFill>
-                <a:latin typeface="Calibri"/>
-              </a:rPr>
-              <a:t>•  Comparison — how this relates to the strongest baseline</a:t>
-            </a:r>
-          </a:p>
-        </p:txBody>
-      </p:sp>
-      <p:sp>
-        <p:nvSpPr>
-          <p:cNvPr id="24" name="TextBox 23"/>
-          <p:cNvSpPr txBox="1"/>
-          <p:nvPr/>
-        </p:nvSpPr>
-        <p:spPr>
-          <a:xfrm>
-            <a:off x="20488776" y="6400800"/>
-            <a:ext cx="8872788" cy="822960"/>
-          </a:xfrm>
-          <a:prstGeom prst="rect">
-            <a:avLst/>
-          </a:prstGeom>
-          <a:noFill/>
-        </p:spPr>
-        <p:txBody>
-          <a:bodyPr wrap="square" lIns="0" rIns="0" tIns="0" bIns="0" anchor="t">
-            <a:spAutoFit/>
-          </a:bodyPr>
-          <a:lstStyle/>
-          <a:p>
-            <a:pPr algn="l"/>
-            <a:r>
-              <a:rPr sz="4800" b="1" i="0">
-                <a:solidFill>
-                  <a:srgbClr val="15296B"/>
-                </a:solidFill>
-                <a:latin typeface="Calibri"/>
-              </a:rPr>
-              <a:t>Conclusion</a:t>
+              <a:t>References</a:t>
             </a:r>
           </a:p>
         </p:txBody>
       </p:sp>
       <p:cxnSp>
         <p:nvCxnSpPr>
-          <p:cNvPr id="25" name="Connector 24"/>
+          <p:cNvPr id="27" name="Connector 26"/>
           <p:cNvCxnSpPr/>
           <p:nvPr/>
         </p:nvCxnSpPr>
         <p:spPr>
           <a:xfrm>
-            <a:off x="20488776" y="7269480"/>
+            <a:off x="15686623" y="29763720"/>
             <a:ext cx="2286000" cy="0"/>
           </a:xfrm>
           <a:prstGeom prst="line">
@@ -4033,14 +4103,14 @@
       </p:cxnSp>
       <p:sp>
         <p:nvSpPr>
-          <p:cNvPr id="26" name="TextBox 25"/>
+          <p:cNvPr id="28" name="TextBox 27"/>
           <p:cNvSpPr txBox="1"/>
           <p:nvPr/>
         </p:nvSpPr>
         <p:spPr>
           <a:xfrm>
-            <a:off x="20488776" y="7498080"/>
-            <a:ext cx="8872788" cy="4572000"/>
+            <a:off x="15686623" y="29992320"/>
+            <a:ext cx="13674943" cy="3474720"/>
           </a:xfrm>
           <a:prstGeom prst="rect">
             <a:avLst/>
@@ -4048,34 +4118,70 @@
           <a:noFill/>
         </p:spPr>
         <p:txBody>
-          <a:bodyPr wrap="square" lIns="0" rIns="0" tIns="0" bIns="0" anchor="t">
+          <a:bodyPr wrap="square" lIns="0" rIns="0" tIns="0" bIns="0">
             <a:spAutoFit/>
           </a:bodyPr>
           <a:lstStyle/>
           <a:p>
-            <a:pPr algn="l"/>
-            <a:r>
-              <a:rPr sz="2600" b="0" i="0">
-                <a:solidFill>
-                  <a:srgbClr val="1F1F1F"/>
+            <a:pPr algn="l">
+              <a:spcAft>
+                <a:spcPts val="1400"/>
+              </a:spcAft>
+            </a:pPr>
+            <a:r>
+              <a:rPr sz="2000">
+                <a:solidFill>
+                  <a:srgbClr val="555555"/>
                 </a:solidFill>
                 <a:latin typeface="Calibri"/>
               </a:rPr>
-              <a:t>Restate the contribution in the terms of the result. Note the one limitation that most shapes when to use (or not use) this approach, and point to the next question it opens up.</a:t>
-            </a:r>
-          </a:p>
-        </p:txBody>
-      </p:sp>
-      <p:sp>
-        <p:nvSpPr>
-          <p:cNvPr id="27" name="TextBox 26"/>
+              <a:t>•  Author, A. et al. (Year). Title. Venue.</a:t>
+            </a:r>
+          </a:p>
+          <a:p>
+            <a:pPr algn="l">
+              <a:spcAft>
+                <a:spcPts val="1400"/>
+              </a:spcAft>
+            </a:pPr>
+            <a:r>
+              <a:rPr sz="2000">
+                <a:solidFill>
+                  <a:srgbClr val="555555"/>
+                </a:solidFill>
+                <a:latin typeface="Calibri"/>
+              </a:rPr>
+              <a:t>•  Author, B. &amp; Author, C. (Year). Title. Venue.</a:t>
+            </a:r>
+          </a:p>
+          <a:p>
+            <a:pPr algn="l">
+              <a:spcAft>
+                <a:spcPts val="1400"/>
+              </a:spcAft>
+            </a:pPr>
+            <a:r>
+              <a:rPr sz="2000">
+                <a:solidFill>
+                  <a:srgbClr val="555555"/>
+                </a:solidFill>
+                <a:latin typeface="Calibri"/>
+              </a:rPr>
+              <a:t>•  Author, D. (Year). Title. Venue.</a:t>
+            </a:r>
+          </a:p>
+        </p:txBody>
+      </p:sp>
+      <p:sp>
+        <p:nvSpPr>
+          <p:cNvPr id="29" name="TextBox 28"/>
           <p:cNvSpPr txBox="1"/>
           <p:nvPr/>
         </p:nvSpPr>
         <p:spPr>
           <a:xfrm>
-            <a:off x="20488776" y="12344400"/>
-            <a:ext cx="8872788" cy="822960"/>
+            <a:off x="15686623" y="33649920"/>
+            <a:ext cx="13674943" cy="822960"/>
           </a:xfrm>
           <a:prstGeom prst="rect">
             <a:avLst/>
@@ -4096,20 +4202,20 @@
                 </a:solidFill>
                 <a:latin typeface="Calibri"/>
               </a:rPr>
-              <a:t>References</a:t>
+              <a:t>Acknowledgements</a:t>
             </a:r>
           </a:p>
         </p:txBody>
       </p:sp>
       <p:cxnSp>
         <p:nvCxnSpPr>
-          <p:cNvPr id="28" name="Connector 27"/>
+          <p:cNvPr id="30" name="Connector 29"/>
           <p:cNvCxnSpPr/>
           <p:nvPr/>
         </p:nvCxnSpPr>
         <p:spPr>
           <a:xfrm>
-            <a:off x="20488776" y="13213080"/>
+            <a:off x="15686623" y="34518600"/>
             <a:ext cx="2286000" cy="0"/>
           </a:xfrm>
           <a:prstGeom prst="line">
@@ -4138,14 +4244,14 @@
       </p:cxnSp>
       <p:sp>
         <p:nvSpPr>
-          <p:cNvPr id="29" name="TextBox 28"/>
+          <p:cNvPr id="31" name="TextBox 30"/>
           <p:cNvSpPr txBox="1"/>
           <p:nvPr/>
         </p:nvSpPr>
         <p:spPr>
           <a:xfrm>
-            <a:off x="20488776" y="13441680"/>
-            <a:ext cx="8872788" cy="4572000"/>
+            <a:off x="15686623" y="34747200"/>
+            <a:ext cx="13674943" cy="1828800"/>
           </a:xfrm>
           <a:prstGeom prst="rect">
             <a:avLst/>
@@ -4153,77 +4259,6 @@
           <a:noFill/>
         </p:spPr>
         <p:txBody>
-          <a:bodyPr wrap="square" lIns="0" rIns="0" tIns="0" bIns="0">
-            <a:spAutoFit/>
-          </a:bodyPr>
-          <a:lstStyle/>
-          <a:p>
-            <a:pPr algn="l">
-              <a:spcAft>
-                <a:spcPts val="1400"/>
-              </a:spcAft>
-            </a:pPr>
-            <a:r>
-              <a:rPr sz="2000">
-                <a:solidFill>
-                  <a:srgbClr val="555555"/>
-                </a:solidFill>
-                <a:latin typeface="Calibri"/>
-              </a:rPr>
-              <a:t>•  Author, A. et al. (Year). Title. Venue.</a:t>
-            </a:r>
-          </a:p>
-          <a:p>
-            <a:pPr algn="l">
-              <a:spcAft>
-                <a:spcPts val="1400"/>
-              </a:spcAft>
-            </a:pPr>
-            <a:r>
-              <a:rPr sz="2000">
-                <a:solidFill>
-                  <a:srgbClr val="555555"/>
-                </a:solidFill>
-                <a:latin typeface="Calibri"/>
-              </a:rPr>
-              <a:t>•  Author, B. &amp; Author, C. (Year). Title. Venue.</a:t>
-            </a:r>
-          </a:p>
-          <a:p>
-            <a:pPr algn="l">
-              <a:spcAft>
-                <a:spcPts val="1400"/>
-              </a:spcAft>
-            </a:pPr>
-            <a:r>
-              <a:rPr sz="2000">
-                <a:solidFill>
-                  <a:srgbClr val="555555"/>
-                </a:solidFill>
-                <a:latin typeface="Calibri"/>
-              </a:rPr>
-              <a:t>•  Author, D. (Year). Title. Venue.</a:t>
-            </a:r>
-          </a:p>
-        </p:txBody>
-      </p:sp>
-      <p:sp>
-        <p:nvSpPr>
-          <p:cNvPr id="30" name="TextBox 29"/>
-          <p:cNvSpPr txBox="1"/>
-          <p:nvPr/>
-        </p:nvSpPr>
-        <p:spPr>
-          <a:xfrm>
-            <a:off x="20488776" y="18196560"/>
-            <a:ext cx="8872788" cy="822960"/>
-          </a:xfrm>
-          <a:prstGeom prst="rect">
-            <a:avLst/>
-          </a:prstGeom>
-          <a:noFill/>
-        </p:spPr>
-        <p:txBody>
           <a:bodyPr wrap="square" lIns="0" rIns="0" tIns="0" bIns="0" anchor="t">
             <a:spAutoFit/>
           </a:bodyPr>
@@ -4231,32 +4266,32 @@
           <a:p>
             <a:pPr algn="l"/>
             <a:r>
-              <a:rPr sz="4800" b="1" i="0">
-                <a:solidFill>
-                  <a:srgbClr val="15296B"/>
+              <a:rPr sz="2000" b="0" i="1">
+                <a:solidFill>
+                  <a:srgbClr val="555555"/>
                 </a:solidFill>
                 <a:latin typeface="Calibri"/>
               </a:rPr>
-              <a:t>Acknowledgements</a:t>
+              <a:t>Funding, collaborators, and compute providers who made this work possible.</a:t>
             </a:r>
           </a:p>
         </p:txBody>
       </p:sp>
       <p:cxnSp>
         <p:nvCxnSpPr>
-          <p:cNvPr id="31" name="Connector 30"/>
+          <p:cNvPr id="32" name="Connector 31"/>
           <p:cNvCxnSpPr/>
           <p:nvPr/>
         </p:nvCxnSpPr>
         <p:spPr>
           <a:xfrm>
-            <a:off x="20488776" y="19065240"/>
-            <a:ext cx="2286000" cy="0"/>
+            <a:off x="914400" y="41432378"/>
+            <a:ext cx="28447166" cy="0"/>
           </a:xfrm>
           <a:prstGeom prst="line">
             <a:avLst/>
           </a:prstGeom>
-          <a:ln w="38100">
+          <a:ln w="25400">
             <a:solidFill>
               <a:srgbClr val="1F3A93"/>
             </a:solidFill>
@@ -4279,14 +4314,14 @@
       </p:cxnSp>
       <p:sp>
         <p:nvSpPr>
-          <p:cNvPr id="32" name="TextBox 31"/>
+          <p:cNvPr id="33" name="TextBox 32"/>
           <p:cNvSpPr txBox="1"/>
           <p:nvPr/>
         </p:nvSpPr>
         <p:spPr>
           <a:xfrm>
-            <a:off x="20488776" y="19293840"/>
-            <a:ext cx="8872788" cy="2286000"/>
+            <a:off x="914400" y="41660978"/>
+            <a:ext cx="28447166" cy="548640"/>
           </a:xfrm>
           <a:prstGeom prst="rect">
             <a:avLst/>
@@ -4301,52 +4336,17 @@
           <a:p>
             <a:pPr algn="l"/>
             <a:r>
-              <a:rPr sz="2000" b="0" i="1">
-                <a:solidFill>
-                  <a:srgbClr val="555555"/>
+              <a:rPr sz="2400" b="0" i="0">
+                <a:solidFill>
+                  <a:srgbClr val="1F1F1F"/>
                 </a:solidFill>
                 <a:latin typeface="Calibri"/>
               </a:rPr>
-              <a:t>Funding, collaborators, and compute providers who made this work possible.</a:t>
-            </a:r>
-          </a:p>
-        </p:txBody>
-      </p:sp>
-      <p:cxnSp>
-        <p:nvCxnSpPr>
-          <p:cNvPr id="33" name="Connector 32"/>
-          <p:cNvCxnSpPr/>
-          <p:nvPr/>
-        </p:nvCxnSpPr>
-        <p:spPr>
-          <a:xfrm>
-            <a:off x="914400" y="41432378"/>
-            <a:ext cx="28447166" cy="0"/>
-          </a:xfrm>
-          <a:prstGeom prst="line">
-            <a:avLst/>
-          </a:prstGeom>
-          <a:ln w="25400">
-            <a:solidFill>
-              <a:srgbClr val="1F3A93"/>
-            </a:solidFill>
-          </a:ln>
-        </p:spPr>
-        <p:style>
-          <a:lnRef idx="2">
-            <a:schemeClr val="accent1"/>
-          </a:lnRef>
-          <a:fillRef idx="0">
-            <a:schemeClr val="accent1"/>
-          </a:fillRef>
-          <a:effectRef idx="1">
-            <a:schemeClr val="accent1"/>
-          </a:effectRef>
-          <a:fontRef idx="minor">
-            <a:schemeClr val="tx1"/>
-          </a:fontRef>
-        </p:style>
-      </p:cxnSp>
+              <a:t>speaker@kcl.ac.uk  ·  kclnlp.github.io  ·  @kclnlp</a:t>
+            </a:r>
+          </a:p>
+        </p:txBody>
+      </p:sp>
       <p:sp>
         <p:nvSpPr>
           <p:cNvPr id="34" name="TextBox 33"/>
@@ -4355,8 +4355,8 @@
         </p:nvSpPr>
         <p:spPr>
           <a:xfrm>
-            <a:off x="914400" y="41660978"/>
-            <a:ext cx="28447166" cy="548640"/>
+            <a:off x="914400" y="42118178"/>
+            <a:ext cx="28447166" cy="457200"/>
           </a:xfrm>
           <a:prstGeom prst="rect">
             <a:avLst/>
@@ -4371,41 +4371,6 @@
           <a:p>
             <a:pPr algn="l"/>
             <a:r>
-              <a:rPr sz="2400" b="0" i="0">
-                <a:solidFill>
-                  <a:srgbClr val="1F1F1F"/>
-                </a:solidFill>
-                <a:latin typeface="Calibri"/>
-              </a:rPr>
-              <a:t>speaker@kcl.ac.uk  ·  kclnlp.github.io  ·  @kclnlp</a:t>
-            </a:r>
-          </a:p>
-        </p:txBody>
-      </p:sp>
-      <p:sp>
-        <p:nvSpPr>
-          <p:cNvPr id="35" name="TextBox 34"/>
-          <p:cNvSpPr txBox="1"/>
-          <p:nvPr/>
-        </p:nvSpPr>
-        <p:spPr>
-          <a:xfrm>
-            <a:off x="914400" y="42118178"/>
-            <a:ext cx="28447166" cy="457200"/>
-          </a:xfrm>
-          <a:prstGeom prst="rect">
-            <a:avLst/>
-          </a:prstGeom>
-          <a:noFill/>
-        </p:spPr>
-        <p:txBody>
-          <a:bodyPr wrap="square" lIns="0" rIns="0" tIns="0" bIns="0" anchor="t">
-            <a:spAutoFit/>
-          </a:bodyPr>
-          <a:lstStyle/>
-          <a:p>
-            <a:pPr algn="l"/>
-            <a:r>
               <a:rPr sz="2000" b="0" i="1">
                 <a:solidFill>
                   <a:srgbClr val="555555"/>
@@ -4419,7 +4384,7 @@
       </p:sp>
       <p:sp>
         <p:nvSpPr>
-          <p:cNvPr id="36" name="Rectangle 35"/>
+          <p:cNvPr id="35" name="Rectangle 34"/>
           <p:cNvSpPr/>
           <p:nvPr/>
         </p:nvSpPr>
@@ -4462,7 +4427,7 @@
       </p:sp>
       <p:sp>
         <p:nvSpPr>
-          <p:cNvPr id="37" name="TextBox 36"/>
+          <p:cNvPr id="36" name="TextBox 35"/>
           <p:cNvSpPr txBox="1"/>
           <p:nvPr/>
         </p:nvSpPr>

</xml_diff>